<commit_message>
Update presentation file with latest local changes
</commit_message>
<xml_diff>
--- a/미적분_탐험대_발표자료.pptx
+++ b/미적분_탐험대_발표자료.pptx
@@ -5,18 +5,18 @@
     <p:sldMasterId id="2147483648" r:id="rId1"/>
   </p:sldMasterIdLst>
   <p:sldIdLst>
-    <p:sldId id="256" r:id="rId7"/>
-    <p:sldId id="257" r:id="rId8"/>
-    <p:sldId id="258" r:id="rId9"/>
-    <p:sldId id="259" r:id="rId10"/>
-    <p:sldId id="260" r:id="rId11"/>
-    <p:sldId id="261" r:id="rId12"/>
-    <p:sldId id="262" r:id="rId13"/>
-    <p:sldId id="263" r:id="rId14"/>
-    <p:sldId id="264" r:id="rId15"/>
-    <p:sldId id="265" r:id="rId16"/>
+    <p:sldId id="256" r:id="rId2"/>
+    <p:sldId id="257" r:id="rId3"/>
+    <p:sldId id="258" r:id="rId4"/>
+    <p:sldId id="259" r:id="rId5"/>
+    <p:sldId id="260" r:id="rId6"/>
+    <p:sldId id="261" r:id="rId7"/>
+    <p:sldId id="262" r:id="rId8"/>
+    <p:sldId id="263" r:id="rId9"/>
+    <p:sldId id="264" r:id="rId10"/>
+    <p:sldId id="265" r:id="rId11"/>
   </p:sldIdLst>
-  <p:sldSz cx="12188952" cy="6858000" type="screen4x3"/>
+  <p:sldSz cx="12188825" cy="6858000"/>
   <p:notesSz cx="6858000" cy="9144000"/>
   <p:defaultTextStyle>
     <a:defPPr>
@@ -113,6 +113,22 @@
       </a:defRPr>
     </a:lvl9pPr>
   </p:defaultTextStyle>
+  <p:extLst>
+    <p:ext uri="{EFAFB233-063F-42B5-8137-9DF3F51BA10A}">
+      <p15:sldGuideLst xmlns:p15="http://schemas.microsoft.com/office/powerpoint/2012/main">
+        <p15:guide id="1" orient="horz" pos="2160">
+          <p15:clr>
+            <a:srgbClr val="A4A3A4"/>
+          </p15:clr>
+        </p15:guide>
+        <p15:guide id="2" pos="2880">
+          <p15:clr>
+            <a:srgbClr val="A4A3A4"/>
+          </p15:clr>
+        </p15:guide>
+      </p15:sldGuideLst>
+    </p:ext>
+  </p:extLst>
 </p:presentation>
 </file>
 
@@ -154,10 +170,9 @@
           <a:lstStyle/>
           <a:p>
             <a:r>
-              <a:rPr lang="en-US" smtClean="0"/>
+              <a:rPr lang="en-US"/>
               <a:t>Click to edit Master title style</a:t>
             </a:r>
-            <a:endParaRPr lang="en-US"/>
           </a:p>
         </p:txBody>
       </p:sp>
@@ -273,10 +288,9 @@
           </a:lstStyle>
           <a:p>
             <a:r>
-              <a:rPr lang="en-US" smtClean="0"/>
+              <a:rPr lang="en-US"/>
               <a:t>Click to edit Master subtitle style</a:t>
             </a:r>
-            <a:endParaRPr lang="en-US"/>
           </a:p>
         </p:txBody>
       </p:sp>
@@ -297,7 +311,7 @@
           <a:p>
             <a:fld id="{5BCAD085-E8A6-8845-BD4E-CB4CCA059FC4}" type="datetimeFigureOut">
               <a:rPr lang="en-US" smtClean="0"/>
-              <a:t>1/27/13</a:t>
+              <a:t>5/9/2026</a:t>
             </a:fld>
             <a:endParaRPr lang="en-US"/>
           </a:p>
@@ -391,10 +405,9 @@
           <a:lstStyle/>
           <a:p>
             <a:r>
-              <a:rPr lang="en-US" smtClean="0"/>
+              <a:rPr lang="en-US"/>
               <a:t>Click to edit Master title style</a:t>
             </a:r>
-            <a:endParaRPr lang="en-US"/>
           </a:p>
         </p:txBody>
       </p:sp>
@@ -415,38 +428,37 @@
           <a:p>
             <a:pPr lvl="0"/>
             <a:r>
-              <a:rPr lang="en-US" smtClean="0"/>
+              <a:rPr lang="en-US"/>
               <a:t>Click to edit Master text styles</a:t>
             </a:r>
           </a:p>
           <a:p>
             <a:pPr lvl="1"/>
             <a:r>
-              <a:rPr lang="en-US" smtClean="0"/>
+              <a:rPr lang="en-US"/>
               <a:t>Second level</a:t>
             </a:r>
           </a:p>
           <a:p>
             <a:pPr lvl="2"/>
             <a:r>
-              <a:rPr lang="en-US" smtClean="0"/>
+              <a:rPr lang="en-US"/>
               <a:t>Third level</a:t>
             </a:r>
           </a:p>
           <a:p>
             <a:pPr lvl="3"/>
             <a:r>
-              <a:rPr lang="en-US" smtClean="0"/>
+              <a:rPr lang="en-US"/>
               <a:t>Fourth level</a:t>
             </a:r>
           </a:p>
           <a:p>
             <a:pPr lvl="4"/>
             <a:r>
-              <a:rPr lang="en-US" smtClean="0"/>
+              <a:rPr lang="en-US"/>
               <a:t>Fifth level</a:t>
             </a:r>
-            <a:endParaRPr lang="en-US"/>
           </a:p>
         </p:txBody>
       </p:sp>
@@ -467,7 +479,7 @@
           <a:p>
             <a:fld id="{5BCAD085-E8A6-8845-BD4E-CB4CCA059FC4}" type="datetimeFigureOut">
               <a:rPr lang="en-US" smtClean="0"/>
-              <a:t>1/27/13</a:t>
+              <a:t>5/9/2026</a:t>
             </a:fld>
             <a:endParaRPr lang="en-US"/>
           </a:p>
@@ -566,10 +578,9 @@
           <a:lstStyle/>
           <a:p>
             <a:r>
-              <a:rPr lang="en-US" smtClean="0"/>
+              <a:rPr lang="en-US"/>
               <a:t>Click to edit Master title style</a:t>
             </a:r>
-            <a:endParaRPr lang="en-US"/>
           </a:p>
         </p:txBody>
       </p:sp>
@@ -595,38 +606,37 @@
           <a:p>
             <a:pPr lvl="0"/>
             <a:r>
-              <a:rPr lang="en-US" smtClean="0"/>
+              <a:rPr lang="en-US"/>
               <a:t>Click to edit Master text styles</a:t>
             </a:r>
           </a:p>
           <a:p>
             <a:pPr lvl="1"/>
             <a:r>
-              <a:rPr lang="en-US" smtClean="0"/>
+              <a:rPr lang="en-US"/>
               <a:t>Second level</a:t>
             </a:r>
           </a:p>
           <a:p>
             <a:pPr lvl="2"/>
             <a:r>
-              <a:rPr lang="en-US" smtClean="0"/>
+              <a:rPr lang="en-US"/>
               <a:t>Third level</a:t>
             </a:r>
           </a:p>
           <a:p>
             <a:pPr lvl="3"/>
             <a:r>
-              <a:rPr lang="en-US" smtClean="0"/>
+              <a:rPr lang="en-US"/>
               <a:t>Fourth level</a:t>
             </a:r>
           </a:p>
           <a:p>
             <a:pPr lvl="4"/>
             <a:r>
-              <a:rPr lang="en-US" smtClean="0"/>
+              <a:rPr lang="en-US"/>
               <a:t>Fifth level</a:t>
             </a:r>
-            <a:endParaRPr lang="en-US"/>
           </a:p>
         </p:txBody>
       </p:sp>
@@ -647,7 +657,7 @@
           <a:p>
             <a:fld id="{5BCAD085-E8A6-8845-BD4E-CB4CCA059FC4}" type="datetimeFigureOut">
               <a:rPr lang="en-US" smtClean="0"/>
-              <a:t>1/27/13</a:t>
+              <a:t>5/9/2026</a:t>
             </a:fld>
             <a:endParaRPr lang="en-US"/>
           </a:p>
@@ -741,10 +751,9 @@
           <a:lstStyle/>
           <a:p>
             <a:r>
-              <a:rPr lang="en-US" smtClean="0"/>
+              <a:rPr lang="en-US"/>
               <a:t>Click to edit Master title style</a:t>
             </a:r>
-            <a:endParaRPr lang="en-US"/>
           </a:p>
         </p:txBody>
       </p:sp>
@@ -765,38 +774,37 @@
           <a:p>
             <a:pPr lvl="0"/>
             <a:r>
-              <a:rPr lang="en-US" smtClean="0"/>
+              <a:rPr lang="en-US"/>
               <a:t>Click to edit Master text styles</a:t>
             </a:r>
           </a:p>
           <a:p>
             <a:pPr lvl="1"/>
             <a:r>
-              <a:rPr lang="en-US" smtClean="0"/>
+              <a:rPr lang="en-US"/>
               <a:t>Second level</a:t>
             </a:r>
           </a:p>
           <a:p>
             <a:pPr lvl="2"/>
             <a:r>
-              <a:rPr lang="en-US" smtClean="0"/>
+              <a:rPr lang="en-US"/>
               <a:t>Third level</a:t>
             </a:r>
           </a:p>
           <a:p>
             <a:pPr lvl="3"/>
             <a:r>
-              <a:rPr lang="en-US" smtClean="0"/>
+              <a:rPr lang="en-US"/>
               <a:t>Fourth level</a:t>
             </a:r>
           </a:p>
           <a:p>
             <a:pPr lvl="4"/>
             <a:r>
-              <a:rPr lang="en-US" smtClean="0"/>
+              <a:rPr lang="en-US"/>
               <a:t>Fifth level</a:t>
             </a:r>
-            <a:endParaRPr lang="en-US"/>
           </a:p>
         </p:txBody>
       </p:sp>
@@ -817,7 +825,7 @@
           <a:p>
             <a:fld id="{5BCAD085-E8A6-8845-BD4E-CB4CCA059FC4}" type="datetimeFigureOut">
               <a:rPr lang="en-US" smtClean="0"/>
-              <a:t>1/27/13</a:t>
+              <a:t>5/9/2026</a:t>
             </a:fld>
             <a:endParaRPr lang="en-US"/>
           </a:p>
@@ -920,10 +928,9 @@
           </a:lstStyle>
           <a:p>
             <a:r>
-              <a:rPr lang="en-US" smtClean="0"/>
+              <a:rPr lang="en-US"/>
               <a:t>Click to edit Master title style</a:t>
             </a:r>
-            <a:endParaRPr lang="en-US"/>
           </a:p>
         </p:txBody>
       </p:sp>
@@ -1040,7 +1047,7 @@
           <a:p>
             <a:pPr lvl="0"/>
             <a:r>
-              <a:rPr lang="en-US" smtClean="0"/>
+              <a:rPr lang="en-US"/>
               <a:t>Click to edit Master text styles</a:t>
             </a:r>
           </a:p>
@@ -1063,7 +1070,7 @@
           <a:p>
             <a:fld id="{5BCAD085-E8A6-8845-BD4E-CB4CCA059FC4}" type="datetimeFigureOut">
               <a:rPr lang="en-US" smtClean="0"/>
-              <a:t>1/27/13</a:t>
+              <a:t>5/9/2026</a:t>
             </a:fld>
             <a:endParaRPr lang="en-US"/>
           </a:p>
@@ -1157,10 +1164,9 @@
           <a:lstStyle/>
           <a:p>
             <a:r>
-              <a:rPr lang="en-US" smtClean="0"/>
+              <a:rPr lang="en-US"/>
               <a:t>Click to edit Master title style</a:t>
             </a:r>
-            <a:endParaRPr lang="en-US"/>
           </a:p>
         </p:txBody>
       </p:sp>
@@ -1214,38 +1220,37 @@
           <a:p>
             <a:pPr lvl="0"/>
             <a:r>
-              <a:rPr lang="en-US" smtClean="0"/>
+              <a:rPr lang="en-US"/>
               <a:t>Click to edit Master text styles</a:t>
             </a:r>
           </a:p>
           <a:p>
             <a:pPr lvl="1"/>
             <a:r>
-              <a:rPr lang="en-US" smtClean="0"/>
+              <a:rPr lang="en-US"/>
               <a:t>Second level</a:t>
             </a:r>
           </a:p>
           <a:p>
             <a:pPr lvl="2"/>
             <a:r>
-              <a:rPr lang="en-US" smtClean="0"/>
+              <a:rPr lang="en-US"/>
               <a:t>Third level</a:t>
             </a:r>
           </a:p>
           <a:p>
             <a:pPr lvl="3"/>
             <a:r>
-              <a:rPr lang="en-US" smtClean="0"/>
+              <a:rPr lang="en-US"/>
               <a:t>Fourth level</a:t>
             </a:r>
           </a:p>
           <a:p>
             <a:pPr lvl="4"/>
             <a:r>
-              <a:rPr lang="en-US" smtClean="0"/>
+              <a:rPr lang="en-US"/>
               <a:t>Fifth level</a:t>
             </a:r>
-            <a:endParaRPr lang="en-US"/>
           </a:p>
         </p:txBody>
       </p:sp>
@@ -1299,38 +1304,37 @@
           <a:p>
             <a:pPr lvl="0"/>
             <a:r>
-              <a:rPr lang="en-US" smtClean="0"/>
+              <a:rPr lang="en-US"/>
               <a:t>Click to edit Master text styles</a:t>
             </a:r>
           </a:p>
           <a:p>
             <a:pPr lvl="1"/>
             <a:r>
-              <a:rPr lang="en-US" smtClean="0"/>
+              <a:rPr lang="en-US"/>
               <a:t>Second level</a:t>
             </a:r>
           </a:p>
           <a:p>
             <a:pPr lvl="2"/>
             <a:r>
-              <a:rPr lang="en-US" smtClean="0"/>
+              <a:rPr lang="en-US"/>
               <a:t>Third level</a:t>
             </a:r>
           </a:p>
           <a:p>
             <a:pPr lvl="3"/>
             <a:r>
-              <a:rPr lang="en-US" smtClean="0"/>
+              <a:rPr lang="en-US"/>
               <a:t>Fourth level</a:t>
             </a:r>
           </a:p>
           <a:p>
             <a:pPr lvl="4"/>
             <a:r>
-              <a:rPr lang="en-US" smtClean="0"/>
+              <a:rPr lang="en-US"/>
               <a:t>Fifth level</a:t>
             </a:r>
-            <a:endParaRPr lang="en-US"/>
           </a:p>
         </p:txBody>
       </p:sp>
@@ -1351,7 +1355,7 @@
           <a:p>
             <a:fld id="{5BCAD085-E8A6-8845-BD4E-CB4CCA059FC4}" type="datetimeFigureOut">
               <a:rPr lang="en-US" smtClean="0"/>
-              <a:t>1/27/13</a:t>
+              <a:t>5/9/2026</a:t>
             </a:fld>
             <a:endParaRPr lang="en-US"/>
           </a:p>
@@ -1449,10 +1453,9 @@
           </a:lstStyle>
           <a:p>
             <a:r>
-              <a:rPr lang="en-US" smtClean="0"/>
+              <a:rPr lang="en-US"/>
               <a:t>Click to edit Master title style</a:t>
             </a:r>
-            <a:endParaRPr lang="en-US"/>
           </a:p>
         </p:txBody>
       </p:sp>
@@ -1515,7 +1518,7 @@
           <a:p>
             <a:pPr lvl="0"/>
             <a:r>
-              <a:rPr lang="en-US" smtClean="0"/>
+              <a:rPr lang="en-US"/>
               <a:t>Click to edit Master text styles</a:t>
             </a:r>
           </a:p>
@@ -1571,38 +1574,37 @@
           <a:p>
             <a:pPr lvl="0"/>
             <a:r>
-              <a:rPr lang="en-US" smtClean="0"/>
+              <a:rPr lang="en-US"/>
               <a:t>Click to edit Master text styles</a:t>
             </a:r>
           </a:p>
           <a:p>
             <a:pPr lvl="1"/>
             <a:r>
-              <a:rPr lang="en-US" smtClean="0"/>
+              <a:rPr lang="en-US"/>
               <a:t>Second level</a:t>
             </a:r>
           </a:p>
           <a:p>
             <a:pPr lvl="2"/>
             <a:r>
-              <a:rPr lang="en-US" smtClean="0"/>
+              <a:rPr lang="en-US"/>
               <a:t>Third level</a:t>
             </a:r>
           </a:p>
           <a:p>
             <a:pPr lvl="3"/>
             <a:r>
-              <a:rPr lang="en-US" smtClean="0"/>
+              <a:rPr lang="en-US"/>
               <a:t>Fourth level</a:t>
             </a:r>
           </a:p>
           <a:p>
             <a:pPr lvl="4"/>
             <a:r>
-              <a:rPr lang="en-US" smtClean="0"/>
+              <a:rPr lang="en-US"/>
               <a:t>Fifth level</a:t>
             </a:r>
-            <a:endParaRPr lang="en-US"/>
           </a:p>
         </p:txBody>
       </p:sp>
@@ -1665,7 +1667,7 @@
           <a:p>
             <a:pPr lvl="0"/>
             <a:r>
-              <a:rPr lang="en-US" smtClean="0"/>
+              <a:rPr lang="en-US"/>
               <a:t>Click to edit Master text styles</a:t>
             </a:r>
           </a:p>
@@ -1721,38 +1723,37 @@
           <a:p>
             <a:pPr lvl="0"/>
             <a:r>
-              <a:rPr lang="en-US" smtClean="0"/>
+              <a:rPr lang="en-US"/>
               <a:t>Click to edit Master text styles</a:t>
             </a:r>
           </a:p>
           <a:p>
             <a:pPr lvl="1"/>
             <a:r>
-              <a:rPr lang="en-US" smtClean="0"/>
+              <a:rPr lang="en-US"/>
               <a:t>Second level</a:t>
             </a:r>
           </a:p>
           <a:p>
             <a:pPr lvl="2"/>
             <a:r>
-              <a:rPr lang="en-US" smtClean="0"/>
+              <a:rPr lang="en-US"/>
               <a:t>Third level</a:t>
             </a:r>
           </a:p>
           <a:p>
             <a:pPr lvl="3"/>
             <a:r>
-              <a:rPr lang="en-US" smtClean="0"/>
+              <a:rPr lang="en-US"/>
               <a:t>Fourth level</a:t>
             </a:r>
           </a:p>
           <a:p>
             <a:pPr lvl="4"/>
             <a:r>
-              <a:rPr lang="en-US" smtClean="0"/>
+              <a:rPr lang="en-US"/>
               <a:t>Fifth level</a:t>
             </a:r>
-            <a:endParaRPr lang="en-US"/>
           </a:p>
         </p:txBody>
       </p:sp>
@@ -1773,7 +1774,7 @@
           <a:p>
             <a:fld id="{5BCAD085-E8A6-8845-BD4E-CB4CCA059FC4}" type="datetimeFigureOut">
               <a:rPr lang="en-US" smtClean="0"/>
-              <a:t>1/27/13</a:t>
+              <a:t>5/9/2026</a:t>
             </a:fld>
             <a:endParaRPr lang="en-US"/>
           </a:p>
@@ -1867,10 +1868,9 @@
           <a:lstStyle/>
           <a:p>
             <a:r>
-              <a:rPr lang="en-US" smtClean="0"/>
+              <a:rPr lang="en-US"/>
               <a:t>Click to edit Master title style</a:t>
             </a:r>
-            <a:endParaRPr lang="en-US"/>
           </a:p>
         </p:txBody>
       </p:sp>
@@ -1891,7 +1891,7 @@
           <a:p>
             <a:fld id="{5BCAD085-E8A6-8845-BD4E-CB4CCA059FC4}" type="datetimeFigureOut">
               <a:rPr lang="en-US" smtClean="0"/>
-              <a:t>1/27/13</a:t>
+              <a:t>5/9/2026</a:t>
             </a:fld>
             <a:endParaRPr lang="en-US"/>
           </a:p>
@@ -1986,7 +1986,7 @@
           <a:p>
             <a:fld id="{5BCAD085-E8A6-8845-BD4E-CB4CCA059FC4}" type="datetimeFigureOut">
               <a:rPr lang="en-US" smtClean="0"/>
-              <a:t>1/27/13</a:t>
+              <a:t>5/9/2026</a:t>
             </a:fld>
             <a:endParaRPr lang="en-US"/>
           </a:p>
@@ -2089,10 +2089,9 @@
           </a:lstStyle>
           <a:p>
             <a:r>
-              <a:rPr lang="en-US" smtClean="0"/>
+              <a:rPr lang="en-US"/>
               <a:t>Click to edit Master title style</a:t>
             </a:r>
-            <a:endParaRPr lang="en-US"/>
           </a:p>
         </p:txBody>
       </p:sp>
@@ -2146,38 +2145,37 @@
           <a:p>
             <a:pPr lvl="0"/>
             <a:r>
-              <a:rPr lang="en-US" smtClean="0"/>
+              <a:rPr lang="en-US"/>
               <a:t>Click to edit Master text styles</a:t>
             </a:r>
           </a:p>
           <a:p>
             <a:pPr lvl="1"/>
             <a:r>
-              <a:rPr lang="en-US" smtClean="0"/>
+              <a:rPr lang="en-US"/>
               <a:t>Second level</a:t>
             </a:r>
           </a:p>
           <a:p>
             <a:pPr lvl="2"/>
             <a:r>
-              <a:rPr lang="en-US" smtClean="0"/>
+              <a:rPr lang="en-US"/>
               <a:t>Third level</a:t>
             </a:r>
           </a:p>
           <a:p>
             <a:pPr lvl="3"/>
             <a:r>
-              <a:rPr lang="en-US" smtClean="0"/>
+              <a:rPr lang="en-US"/>
               <a:t>Fourth level</a:t>
             </a:r>
           </a:p>
           <a:p>
             <a:pPr lvl="4"/>
             <a:r>
-              <a:rPr lang="en-US" smtClean="0"/>
+              <a:rPr lang="en-US"/>
               <a:t>Fifth level</a:t>
             </a:r>
-            <a:endParaRPr lang="en-US"/>
           </a:p>
         </p:txBody>
       </p:sp>
@@ -2240,7 +2238,7 @@
           <a:p>
             <a:pPr lvl="0"/>
             <a:r>
-              <a:rPr lang="en-US" smtClean="0"/>
+              <a:rPr lang="en-US"/>
               <a:t>Click to edit Master text styles</a:t>
             </a:r>
           </a:p>
@@ -2263,7 +2261,7 @@
           <a:p>
             <a:fld id="{5BCAD085-E8A6-8845-BD4E-CB4CCA059FC4}" type="datetimeFigureOut">
               <a:rPr lang="en-US" smtClean="0"/>
-              <a:t>1/27/13</a:t>
+              <a:t>5/9/2026</a:t>
             </a:fld>
             <a:endParaRPr lang="en-US"/>
           </a:p>
@@ -2366,10 +2364,9 @@
           </a:lstStyle>
           <a:p>
             <a:r>
-              <a:rPr lang="en-US" smtClean="0"/>
+              <a:rPr lang="en-US"/>
               <a:t>Click to edit Master title style</a:t>
             </a:r>
-            <a:endParaRPr lang="en-US"/>
           </a:p>
         </p:txBody>
       </p:sp>
@@ -2493,7 +2490,7 @@
           <a:p>
             <a:pPr lvl="0"/>
             <a:r>
-              <a:rPr lang="en-US" smtClean="0"/>
+              <a:rPr lang="en-US"/>
               <a:t>Click to edit Master text styles</a:t>
             </a:r>
           </a:p>
@@ -2516,7 +2513,7 @@
           <a:p>
             <a:fld id="{5BCAD085-E8A6-8845-BD4E-CB4CCA059FC4}" type="datetimeFigureOut">
               <a:rPr lang="en-US" smtClean="0"/>
-              <a:t>1/27/13</a:t>
+              <a:t>5/9/2026</a:t>
             </a:fld>
             <a:endParaRPr lang="en-US"/>
           </a:p>
@@ -2625,10 +2622,9 @@
           <a:lstStyle/>
           <a:p>
             <a:r>
-              <a:rPr lang="en-US" smtClean="0"/>
+              <a:rPr lang="en-US"/>
               <a:t>Click to edit Master title style</a:t>
             </a:r>
-            <a:endParaRPr lang="en-US"/>
           </a:p>
         </p:txBody>
       </p:sp>
@@ -2659,38 +2655,37 @@
           <a:p>
             <a:pPr lvl="0"/>
             <a:r>
-              <a:rPr lang="en-US" smtClean="0"/>
+              <a:rPr lang="en-US"/>
               <a:t>Click to edit Master text styles</a:t>
             </a:r>
           </a:p>
           <a:p>
             <a:pPr lvl="1"/>
             <a:r>
-              <a:rPr lang="en-US" smtClean="0"/>
+              <a:rPr lang="en-US"/>
               <a:t>Second level</a:t>
             </a:r>
           </a:p>
           <a:p>
             <a:pPr lvl="2"/>
             <a:r>
-              <a:rPr lang="en-US" smtClean="0"/>
+              <a:rPr lang="en-US"/>
               <a:t>Third level</a:t>
             </a:r>
           </a:p>
           <a:p>
             <a:pPr lvl="3"/>
             <a:r>
-              <a:rPr lang="en-US" smtClean="0"/>
+              <a:rPr lang="en-US"/>
               <a:t>Fourth level</a:t>
             </a:r>
           </a:p>
           <a:p>
             <a:pPr lvl="4"/>
             <a:r>
-              <a:rPr lang="en-US" smtClean="0"/>
+              <a:rPr lang="en-US"/>
               <a:t>Fifth level</a:t>
             </a:r>
-            <a:endParaRPr lang="en-US"/>
           </a:p>
         </p:txBody>
       </p:sp>
@@ -2729,7 +2724,7 @@
           <a:p>
             <a:fld id="{5BCAD085-E8A6-8845-BD4E-CB4CCA059FC4}" type="datetimeFigureOut">
               <a:rPr lang="en-US" smtClean="0"/>
-              <a:t>1/27/13</a:t>
+              <a:t>5/9/2026</a:t>
             </a:fld>
             <a:endParaRPr lang="en-US"/>
           </a:p>
@@ -3088,7 +3083,7 @@
 </file>
 
 <file path=ppt/slides/slide1.xml><?xml version="1.0" encoding="utf-8"?>
-<p:sld xmlns:a="http://schemas.openxmlformats.org/drawingml/2006/main" xmlns:p="http://schemas.openxmlformats.org/presentationml/2006/main" xmlns:r="http://schemas.openxmlformats.org/officeDocument/2006/relationships">
+<p:sld xmlns:a="http://schemas.openxmlformats.org/drawingml/2006/main" xmlns:r="http://schemas.openxmlformats.org/officeDocument/2006/relationships" xmlns:p="http://schemas.openxmlformats.org/presentationml/2006/main">
   <p:cSld>
     <p:bg>
       <p:bgPr>
@@ -3104,7 +3099,14 @@
         <p:cNvGrpSpPr/>
         <p:nvPr/>
       </p:nvGrpSpPr>
-      <p:grpSpPr/>
+      <p:grpSpPr>
+        <a:xfrm>
+          <a:off x="0" y="0"/>
+          <a:ext cx="0" cy="0"/>
+          <a:chOff x="0" y="0"/>
+          <a:chExt cx="0" cy="0"/>
+        </a:xfrm>
+      </p:grpSpPr>
       <p:sp>
         <p:nvSpPr>
           <p:cNvPr id="2" name="Oval 1"/>
@@ -3120,7 +3122,10 @@
             <a:avLst/>
           </a:prstGeom>
           <a:solidFill>
-            <a:srgbClr val="283A8E"/>
+            <a:schemeClr val="accent4">
+              <a:lumMod val="40000"/>
+              <a:lumOff val="60000"/>
+            </a:schemeClr>
           </a:solidFill>
           <a:ln>
             <a:noFill/>
@@ -3145,6 +3150,7 @@
           <a:lstStyle/>
           <a:p>
             <a:pPr algn="ctr"/>
+            <a:endParaRPr/>
           </a:p>
         </p:txBody>
       </p:sp>
@@ -3163,7 +3169,9 @@
             <a:avLst/>
           </a:prstGeom>
           <a:solidFill>
-            <a:srgbClr val="283A8E"/>
+            <a:schemeClr val="accent6">
+              <a:lumMod val="75000"/>
+            </a:schemeClr>
           </a:solidFill>
           <a:ln>
             <a:noFill/>
@@ -3188,6 +3196,7 @@
           <a:lstStyle/>
           <a:p>
             <a:pPr algn="ctr"/>
+            <a:endParaRPr/>
           </a:p>
         </p:txBody>
       </p:sp>
@@ -3206,7 +3215,7 @@
             <a:avLst/>
           </a:prstGeom>
           <a:solidFill>
-            <a:srgbClr val="283A8E"/>
+            <a:srgbClr val="92D050"/>
           </a:solidFill>
           <a:ln>
             <a:noFill/>
@@ -3231,6 +3240,7 @@
           <a:lstStyle/>
           <a:p>
             <a:pPr algn="ctr"/>
+            <a:endParaRPr/>
           </a:p>
         </p:txBody>
       </p:sp>
@@ -3278,7 +3288,7 @@
         <p:spPr>
           <a:xfrm>
             <a:off x="914400" y="3017520"/>
-            <a:ext cx="10058400" cy="822960"/>
+            <a:ext cx="10058400" cy="523220"/>
           </a:xfrm>
           <a:prstGeom prst="rect">
             <a:avLst/>
@@ -3293,14 +3303,92 @@
           <a:p>
             <a:pPr algn="ctr"/>
             <a:r>
-              <a:rPr sz="2800" b="0">
+              <a:rPr lang="ko-KR" altLang="en-US" sz="2800" dirty="0">
                 <a:solidFill>
                   <a:srgbClr val="BBDEFB"/>
                 </a:solidFill>
                 <a:latin typeface="Malgun Gothic"/>
               </a:rPr>
-              <a:t>초등학생도 이해하는 미분 · 적분 여행</a:t>
-            </a:r>
+              <a:t>수포자</a:t>
+            </a:r>
+            <a:r>
+              <a:rPr sz="2800" b="0" dirty="0">
+                <a:solidFill>
+                  <a:srgbClr val="BBDEFB"/>
+                </a:solidFill>
+                <a:latin typeface="Malgun Gothic"/>
+              </a:rPr>
+              <a:t>도 </a:t>
+            </a:r>
+            <a:r>
+              <a:rPr sz="2800" b="0" dirty="0" err="1">
+                <a:solidFill>
+                  <a:srgbClr val="BBDEFB"/>
+                </a:solidFill>
+                <a:latin typeface="Malgun Gothic"/>
+              </a:rPr>
+              <a:t>이해하는</a:t>
+            </a:r>
+            <a:r>
+              <a:rPr sz="2800" b="0" dirty="0">
+                <a:solidFill>
+                  <a:srgbClr val="BBDEFB"/>
+                </a:solidFill>
+                <a:latin typeface="Malgun Gothic"/>
+              </a:rPr>
+              <a:t> </a:t>
+            </a:r>
+            <a:r>
+              <a:rPr sz="2800" b="0" dirty="0" err="1">
+                <a:solidFill>
+                  <a:srgbClr val="BBDEFB"/>
+                </a:solidFill>
+                <a:latin typeface="Malgun Gothic"/>
+              </a:rPr>
+              <a:t>미분</a:t>
+            </a:r>
+            <a:r>
+              <a:rPr sz="2800" b="0" dirty="0">
+                <a:solidFill>
+                  <a:srgbClr val="BBDEFB"/>
+                </a:solidFill>
+                <a:latin typeface="Malgun Gothic"/>
+              </a:rPr>
+              <a:t> · </a:t>
+            </a:r>
+            <a:r>
+              <a:rPr sz="2800" b="0" dirty="0" err="1">
+                <a:solidFill>
+                  <a:srgbClr val="BBDEFB"/>
+                </a:solidFill>
+                <a:latin typeface="Malgun Gothic"/>
+              </a:rPr>
+              <a:t>적분</a:t>
+            </a:r>
+            <a:r>
+              <a:rPr sz="2800" b="0" dirty="0">
+                <a:solidFill>
+                  <a:srgbClr val="BBDEFB"/>
+                </a:solidFill>
+                <a:latin typeface="Malgun Gothic"/>
+              </a:rPr>
+              <a:t> </a:t>
+            </a:r>
+            <a:r>
+              <a:rPr sz="2800" b="0" dirty="0" err="1">
+                <a:solidFill>
+                  <a:srgbClr val="BBDEFB"/>
+                </a:solidFill>
+                <a:latin typeface="Malgun Gothic"/>
+              </a:rPr>
+              <a:t>여행</a:t>
+            </a:r>
+            <a:endParaRPr sz="2800" b="0" dirty="0">
+              <a:solidFill>
+                <a:srgbClr val="BBDEFB"/>
+              </a:solidFill>
+              <a:latin typeface="Malgun Gothic"/>
+            </a:endParaRPr>
           </a:p>
         </p:txBody>
       </p:sp>
@@ -3383,7 +3471,7 @@
 </file>
 
 <file path=ppt/slides/slide10.xml><?xml version="1.0" encoding="utf-8"?>
-<p:sld xmlns:a="http://schemas.openxmlformats.org/drawingml/2006/main" xmlns:p="http://schemas.openxmlformats.org/presentationml/2006/main" xmlns:r="http://schemas.openxmlformats.org/officeDocument/2006/relationships">
+<p:sld xmlns:a="http://schemas.openxmlformats.org/drawingml/2006/main" xmlns:r="http://schemas.openxmlformats.org/officeDocument/2006/relationships" xmlns:p="http://schemas.openxmlformats.org/presentationml/2006/main">
   <p:cSld>
     <p:bg>
       <p:bgPr>
@@ -3399,7 +3487,14 @@
         <p:cNvGrpSpPr/>
         <p:nvPr/>
       </p:nvGrpSpPr>
-      <p:grpSpPr/>
+      <p:grpSpPr>
+        <a:xfrm>
+          <a:off x="0" y="0"/>
+          <a:ext cx="0" cy="0"/>
+          <a:chOff x="0" y="0"/>
+          <a:chExt cx="0" cy="0"/>
+        </a:xfrm>
+      </p:grpSpPr>
       <p:sp>
         <p:nvSpPr>
           <p:cNvPr id="2" name="TextBox 1"/>
@@ -3475,6 +3570,7 @@
           <a:lstStyle/>
           <a:p>
             <a:pPr algn="ctr"/>
+            <a:endParaRPr/>
           </a:p>
         </p:txBody>
       </p:sp>
@@ -3588,6 +3684,7 @@
           <a:lstStyle/>
           <a:p>
             <a:pPr algn="ctr"/>
+            <a:endParaRPr/>
           </a:p>
         </p:txBody>
       </p:sp>
@@ -3701,6 +3798,7 @@
           <a:lstStyle/>
           <a:p>
             <a:pPr algn="ctr"/>
+            <a:endParaRPr/>
           </a:p>
         </p:txBody>
       </p:sp>
@@ -3814,6 +3912,7 @@
           <a:lstStyle/>
           <a:p>
             <a:pPr algn="ctr"/>
+            <a:endParaRPr/>
           </a:p>
         </p:txBody>
       </p:sp>
@@ -3927,6 +4026,7 @@
           <a:lstStyle/>
           <a:p>
             <a:pPr algn="ctr"/>
+            <a:endParaRPr/>
           </a:p>
         </p:txBody>
       </p:sp>
@@ -4040,6 +4140,7 @@
           <a:lstStyle/>
           <a:p>
             <a:pPr algn="ctr"/>
+            <a:endParaRPr/>
           </a:p>
         </p:txBody>
       </p:sp>
@@ -4157,7 +4258,7 @@
 </file>
 
 <file path=ppt/slides/slide2.xml><?xml version="1.0" encoding="utf-8"?>
-<p:sld xmlns:a="http://schemas.openxmlformats.org/drawingml/2006/main" xmlns:p="http://schemas.openxmlformats.org/presentationml/2006/main" xmlns:r="http://schemas.openxmlformats.org/officeDocument/2006/relationships">
+<p:sld xmlns:a="http://schemas.openxmlformats.org/drawingml/2006/main" xmlns:r="http://schemas.openxmlformats.org/officeDocument/2006/relationships" xmlns:p="http://schemas.openxmlformats.org/presentationml/2006/main">
   <p:cSld>
     <p:bg>
       <p:bgPr>
@@ -4173,7 +4274,14 @@
         <p:cNvGrpSpPr/>
         <p:nvPr/>
       </p:nvGrpSpPr>
-      <p:grpSpPr/>
+      <p:grpSpPr>
+        <a:xfrm>
+          <a:off x="0" y="0"/>
+          <a:ext cx="0" cy="0"/>
+          <a:chOff x="0" y="0"/>
+          <a:chExt cx="0" cy="0"/>
+        </a:xfrm>
+      </p:grpSpPr>
       <p:sp>
         <p:nvSpPr>
           <p:cNvPr id="2" name="Rectangle 1"/>
@@ -4214,6 +4322,7 @@
           <a:lstStyle/>
           <a:p>
             <a:pPr algn="ctr"/>
+            <a:endParaRPr/>
           </a:p>
         </p:txBody>
       </p:sp>
@@ -4292,6 +4401,7 @@
           <a:lstStyle/>
           <a:p>
             <a:pPr algn="ctr"/>
+            <a:endParaRPr/>
           </a:p>
         </p:txBody>
       </p:sp>
@@ -4441,6 +4551,7 @@
           <a:lstStyle/>
           <a:p>
             <a:pPr algn="ctr"/>
+            <a:endParaRPr/>
           </a:p>
         </p:txBody>
       </p:sp>
@@ -4590,6 +4701,7 @@
           <a:lstStyle/>
           <a:p>
             <a:pPr algn="ctr"/>
+            <a:endParaRPr/>
           </a:p>
         </p:txBody>
       </p:sp>
@@ -4739,6 +4851,7 @@
           <a:lstStyle/>
           <a:p>
             <a:pPr algn="ctr"/>
+            <a:endParaRPr/>
           </a:p>
         </p:txBody>
       </p:sp>
@@ -4888,6 +5001,7 @@
           <a:lstStyle/>
           <a:p>
             <a:pPr algn="ctr"/>
+            <a:endParaRPr/>
           </a:p>
         </p:txBody>
       </p:sp>
@@ -5037,6 +5151,7 @@
           <a:lstStyle/>
           <a:p>
             <a:pPr algn="ctr"/>
+            <a:endParaRPr/>
           </a:p>
         </p:txBody>
       </p:sp>
@@ -5155,7 +5270,7 @@
 </file>
 
 <file path=ppt/slides/slide3.xml><?xml version="1.0" encoding="utf-8"?>
-<p:sld xmlns:a="http://schemas.openxmlformats.org/drawingml/2006/main" xmlns:p="http://schemas.openxmlformats.org/presentationml/2006/main" xmlns:r="http://schemas.openxmlformats.org/officeDocument/2006/relationships">
+<p:sld xmlns:a="http://schemas.openxmlformats.org/drawingml/2006/main" xmlns:r="http://schemas.openxmlformats.org/officeDocument/2006/relationships" xmlns:p="http://schemas.openxmlformats.org/presentationml/2006/main">
   <p:cSld>
     <p:bg>
       <p:bgPr>
@@ -5171,7 +5286,14 @@
         <p:cNvGrpSpPr/>
         <p:nvPr/>
       </p:nvGrpSpPr>
-      <p:grpSpPr/>
+      <p:grpSpPr>
+        <a:xfrm>
+          <a:off x="0" y="0"/>
+          <a:ext cx="0" cy="0"/>
+          <a:chOff x="0" y="0"/>
+          <a:chExt cx="0" cy="0"/>
+        </a:xfrm>
+      </p:grpSpPr>
       <p:sp>
         <p:nvSpPr>
           <p:cNvPr id="2" name="Rectangle 1"/>
@@ -5212,6 +5334,7 @@
           <a:lstStyle/>
           <a:p>
             <a:pPr algn="ctr"/>
+            <a:endParaRPr/>
           </a:p>
         </p:txBody>
       </p:sp>
@@ -5290,6 +5413,7 @@
           <a:lstStyle/>
           <a:p>
             <a:pPr algn="ctr"/>
+            <a:endParaRPr/>
           </a:p>
         </p:txBody>
       </p:sp>
@@ -5501,7 +5625,7 @@
 </file>
 
 <file path=ppt/slides/slide4.xml><?xml version="1.0" encoding="utf-8"?>
-<p:sld xmlns:a="http://schemas.openxmlformats.org/drawingml/2006/main" xmlns:p="http://schemas.openxmlformats.org/presentationml/2006/main" xmlns:r="http://schemas.openxmlformats.org/officeDocument/2006/relationships">
+<p:sld xmlns:a="http://schemas.openxmlformats.org/drawingml/2006/main" xmlns:r="http://schemas.openxmlformats.org/officeDocument/2006/relationships" xmlns:p="http://schemas.openxmlformats.org/presentationml/2006/main">
   <p:cSld>
     <p:bg>
       <p:bgPr>
@@ -5517,7 +5641,14 @@
         <p:cNvGrpSpPr/>
         <p:nvPr/>
       </p:nvGrpSpPr>
-      <p:grpSpPr/>
+      <p:grpSpPr>
+        <a:xfrm>
+          <a:off x="0" y="0"/>
+          <a:ext cx="0" cy="0"/>
+          <a:chOff x="0" y="0"/>
+          <a:chExt cx="0" cy="0"/>
+        </a:xfrm>
+      </p:grpSpPr>
       <p:sp>
         <p:nvSpPr>
           <p:cNvPr id="2" name="Rectangle 1"/>
@@ -5558,6 +5689,7 @@
           <a:lstStyle/>
           <a:p>
             <a:pPr algn="ctr"/>
+            <a:endParaRPr/>
           </a:p>
         </p:txBody>
       </p:sp>
@@ -5636,6 +5768,7 @@
           <a:lstStyle/>
           <a:p>
             <a:pPr algn="ctr"/>
+            <a:endParaRPr/>
           </a:p>
         </p:txBody>
       </p:sp>
@@ -5823,7 +5956,7 @@
 </file>
 
 <file path=ppt/slides/slide5.xml><?xml version="1.0" encoding="utf-8"?>
-<p:sld xmlns:a="http://schemas.openxmlformats.org/drawingml/2006/main" xmlns:p="http://schemas.openxmlformats.org/presentationml/2006/main" xmlns:r="http://schemas.openxmlformats.org/officeDocument/2006/relationships">
+<p:sld xmlns:a="http://schemas.openxmlformats.org/drawingml/2006/main" xmlns:r="http://schemas.openxmlformats.org/officeDocument/2006/relationships" xmlns:p="http://schemas.openxmlformats.org/presentationml/2006/main">
   <p:cSld>
     <p:bg>
       <p:bgPr>
@@ -5839,7 +5972,14 @@
         <p:cNvGrpSpPr/>
         <p:nvPr/>
       </p:nvGrpSpPr>
-      <p:grpSpPr/>
+      <p:grpSpPr>
+        <a:xfrm>
+          <a:off x="0" y="0"/>
+          <a:ext cx="0" cy="0"/>
+          <a:chOff x="0" y="0"/>
+          <a:chExt cx="0" cy="0"/>
+        </a:xfrm>
+      </p:grpSpPr>
       <p:sp>
         <p:nvSpPr>
           <p:cNvPr id="2" name="Rectangle 1"/>
@@ -5880,6 +6020,7 @@
           <a:lstStyle/>
           <a:p>
             <a:pPr algn="ctr"/>
+            <a:endParaRPr/>
           </a:p>
         </p:txBody>
       </p:sp>
@@ -5958,6 +6099,7 @@
           <a:lstStyle/>
           <a:p>
             <a:pPr algn="ctr"/>
+            <a:endParaRPr/>
           </a:p>
         </p:txBody>
       </p:sp>
@@ -6204,7 +6346,7 @@
 </file>
 
 <file path=ppt/slides/slide6.xml><?xml version="1.0" encoding="utf-8"?>
-<p:sld xmlns:a="http://schemas.openxmlformats.org/drawingml/2006/main" xmlns:p="http://schemas.openxmlformats.org/presentationml/2006/main" xmlns:r="http://schemas.openxmlformats.org/officeDocument/2006/relationships">
+<p:sld xmlns:a="http://schemas.openxmlformats.org/drawingml/2006/main" xmlns:r="http://schemas.openxmlformats.org/officeDocument/2006/relationships" xmlns:p="http://schemas.openxmlformats.org/presentationml/2006/main">
   <p:cSld>
     <p:bg>
       <p:bgPr>
@@ -6220,7 +6362,14 @@
         <p:cNvGrpSpPr/>
         <p:nvPr/>
       </p:nvGrpSpPr>
-      <p:grpSpPr/>
+      <p:grpSpPr>
+        <a:xfrm>
+          <a:off x="0" y="0"/>
+          <a:ext cx="0" cy="0"/>
+          <a:chOff x="0" y="0"/>
+          <a:chExt cx="0" cy="0"/>
+        </a:xfrm>
+      </p:grpSpPr>
       <p:sp>
         <p:nvSpPr>
           <p:cNvPr id="2" name="Rectangle 1"/>
@@ -6261,6 +6410,7 @@
           <a:lstStyle/>
           <a:p>
             <a:pPr algn="ctr"/>
+            <a:endParaRPr/>
           </a:p>
         </p:txBody>
       </p:sp>
@@ -6339,6 +6489,7 @@
           <a:lstStyle/>
           <a:p>
             <a:pPr algn="ctr"/>
+            <a:endParaRPr/>
           </a:p>
         </p:txBody>
       </p:sp>
@@ -6585,7 +6736,7 @@
 </file>
 
 <file path=ppt/slides/slide7.xml><?xml version="1.0" encoding="utf-8"?>
-<p:sld xmlns:a="http://schemas.openxmlformats.org/drawingml/2006/main" xmlns:p="http://schemas.openxmlformats.org/presentationml/2006/main" xmlns:r="http://schemas.openxmlformats.org/officeDocument/2006/relationships">
+<p:sld xmlns:a="http://schemas.openxmlformats.org/drawingml/2006/main" xmlns:r="http://schemas.openxmlformats.org/officeDocument/2006/relationships" xmlns:p="http://schemas.openxmlformats.org/presentationml/2006/main">
   <p:cSld>
     <p:bg>
       <p:bgPr>
@@ -6601,7 +6752,14 @@
         <p:cNvGrpSpPr/>
         <p:nvPr/>
       </p:nvGrpSpPr>
-      <p:grpSpPr/>
+      <p:grpSpPr>
+        <a:xfrm>
+          <a:off x="0" y="0"/>
+          <a:ext cx="0" cy="0"/>
+          <a:chOff x="0" y="0"/>
+          <a:chExt cx="0" cy="0"/>
+        </a:xfrm>
+      </p:grpSpPr>
       <p:sp>
         <p:nvSpPr>
           <p:cNvPr id="2" name="Rectangle 1"/>
@@ -6642,6 +6800,7 @@
           <a:lstStyle/>
           <a:p>
             <a:pPr algn="ctr"/>
+            <a:endParaRPr/>
           </a:p>
         </p:txBody>
       </p:sp>
@@ -6654,7 +6813,7 @@
         <p:spPr>
           <a:xfrm>
             <a:off x="274320" y="91440"/>
-            <a:ext cx="11430000" cy="822960"/>
+            <a:ext cx="11430000" cy="553998"/>
           </a:xfrm>
           <a:prstGeom prst="rect">
             <a:avLst/>
@@ -6669,14 +6828,47 @@
           <a:p>
             <a:pPr algn="l"/>
             <a:r>
-              <a:rPr sz="3000" b="1">
+              <a:rPr sz="3000" b="1" dirty="0">
                 <a:solidFill>
                   <a:srgbClr val="FFFFFF"/>
                 </a:solidFill>
                 <a:latin typeface="Malgun Gothic"/>
               </a:rPr>
-              <a:t>⚡ Chapter 5. 미분은 기울기다</a:t>
-            </a:r>
+              <a:t>⚡ Chapter 5. </a:t>
+            </a:r>
+            <a:r>
+              <a:rPr sz="3000" b="1" dirty="0" err="1">
+                <a:solidFill>
+                  <a:srgbClr val="FFFFFF"/>
+                </a:solidFill>
+                <a:latin typeface="Malgun Gothic"/>
+              </a:rPr>
+              <a:t>미분은</a:t>
+            </a:r>
+            <a:r>
+              <a:rPr sz="3000" b="1" dirty="0">
+                <a:solidFill>
+                  <a:srgbClr val="FFFFFF"/>
+                </a:solidFill>
+                <a:latin typeface="Malgun Gothic"/>
+              </a:rPr>
+              <a:t> </a:t>
+            </a:r>
+            <a:r>
+              <a:rPr sz="3000" b="1" dirty="0" err="1">
+                <a:solidFill>
+                  <a:srgbClr val="FFFFFF"/>
+                </a:solidFill>
+                <a:latin typeface="Malgun Gothic"/>
+              </a:rPr>
+              <a:t>기울기</a:t>
+            </a:r>
+            <a:endParaRPr sz="3000" b="1" dirty="0">
+              <a:solidFill>
+                <a:srgbClr val="FFFFFF"/>
+              </a:solidFill>
+              <a:latin typeface="Malgun Gothic"/>
+            </a:endParaRPr>
           </a:p>
         </p:txBody>
       </p:sp>
@@ -6720,6 +6912,7 @@
           <a:lstStyle/>
           <a:p>
             <a:pPr algn="ctr"/>
+            <a:endParaRPr/>
           </a:p>
         </p:txBody>
       </p:sp>
@@ -7002,7 +7195,7 @@
 </file>
 
 <file path=ppt/slides/slide8.xml><?xml version="1.0" encoding="utf-8"?>
-<p:sld xmlns:a="http://schemas.openxmlformats.org/drawingml/2006/main" xmlns:p="http://schemas.openxmlformats.org/presentationml/2006/main" xmlns:r="http://schemas.openxmlformats.org/officeDocument/2006/relationships">
+<p:sld xmlns:a="http://schemas.openxmlformats.org/drawingml/2006/main" xmlns:r="http://schemas.openxmlformats.org/officeDocument/2006/relationships" xmlns:p="http://schemas.openxmlformats.org/presentationml/2006/main">
   <p:cSld>
     <p:bg>
       <p:bgPr>
@@ -7018,7 +7211,14 @@
         <p:cNvGrpSpPr/>
         <p:nvPr/>
       </p:nvGrpSpPr>
-      <p:grpSpPr/>
+      <p:grpSpPr>
+        <a:xfrm>
+          <a:off x="0" y="0"/>
+          <a:ext cx="0" cy="0"/>
+          <a:chOff x="0" y="0"/>
+          <a:chExt cx="0" cy="0"/>
+        </a:xfrm>
+      </p:grpSpPr>
       <p:sp>
         <p:nvSpPr>
           <p:cNvPr id="2" name="Rectangle 1"/>
@@ -7059,6 +7259,7 @@
           <a:lstStyle/>
           <a:p>
             <a:pPr algn="ctr"/>
+            <a:endParaRPr/>
           </a:p>
         </p:txBody>
       </p:sp>
@@ -7071,7 +7272,7 @@
         <p:spPr>
           <a:xfrm>
             <a:off x="274320" y="91440"/>
-            <a:ext cx="11430000" cy="822960"/>
+            <a:ext cx="11430000" cy="553998"/>
           </a:xfrm>
           <a:prstGeom prst="rect">
             <a:avLst/>
@@ -7086,14 +7287,47 @@
           <a:p>
             <a:pPr algn="l"/>
             <a:r>
-              <a:rPr sz="3000" b="1">
+              <a:rPr sz="3000" b="1" dirty="0">
                 <a:solidFill>
                   <a:srgbClr val="FFFFFF"/>
                 </a:solidFill>
                 <a:latin typeface="Malgun Gothic"/>
               </a:rPr>
-              <a:t>🏞️ Chapter 6. 적분은 넓이다</a:t>
-            </a:r>
+              <a:t>🏞️ Chapter 6. </a:t>
+            </a:r>
+            <a:r>
+              <a:rPr sz="3000" b="1" dirty="0" err="1">
+                <a:solidFill>
+                  <a:srgbClr val="FFFFFF"/>
+                </a:solidFill>
+                <a:latin typeface="Malgun Gothic"/>
+              </a:rPr>
+              <a:t>적분은</a:t>
+            </a:r>
+            <a:r>
+              <a:rPr sz="3000" b="1" dirty="0">
+                <a:solidFill>
+                  <a:srgbClr val="FFFFFF"/>
+                </a:solidFill>
+                <a:latin typeface="Malgun Gothic"/>
+              </a:rPr>
+              <a:t> </a:t>
+            </a:r>
+            <a:r>
+              <a:rPr sz="3000" b="1" dirty="0" err="1">
+                <a:solidFill>
+                  <a:srgbClr val="FFFFFF"/>
+                </a:solidFill>
+                <a:latin typeface="Malgun Gothic"/>
+              </a:rPr>
+              <a:t>넓이</a:t>
+            </a:r>
+            <a:endParaRPr sz="3000" b="1" dirty="0">
+              <a:solidFill>
+                <a:srgbClr val="FFFFFF"/>
+              </a:solidFill>
+              <a:latin typeface="Malgun Gothic"/>
+            </a:endParaRPr>
           </a:p>
         </p:txBody>
       </p:sp>
@@ -7137,6 +7371,7 @@
           <a:lstStyle/>
           <a:p>
             <a:pPr algn="ctr"/>
+            <a:endParaRPr/>
           </a:p>
         </p:txBody>
       </p:sp>
@@ -7442,7 +7677,7 @@
 </file>
 
 <file path=ppt/slides/slide9.xml><?xml version="1.0" encoding="utf-8"?>
-<p:sld xmlns:a="http://schemas.openxmlformats.org/drawingml/2006/main" xmlns:p="http://schemas.openxmlformats.org/presentationml/2006/main" xmlns:r="http://schemas.openxmlformats.org/officeDocument/2006/relationships">
+<p:sld xmlns:a="http://schemas.openxmlformats.org/drawingml/2006/main" xmlns:r="http://schemas.openxmlformats.org/officeDocument/2006/relationships" xmlns:p="http://schemas.openxmlformats.org/presentationml/2006/main">
   <p:cSld>
     <p:bg>
       <p:bgPr>
@@ -7458,7 +7693,14 @@
         <p:cNvGrpSpPr/>
         <p:nvPr/>
       </p:nvGrpSpPr>
-      <p:grpSpPr/>
+      <p:grpSpPr>
+        <a:xfrm>
+          <a:off x="0" y="0"/>
+          <a:ext cx="0" cy="0"/>
+          <a:chOff x="0" y="0"/>
+          <a:chExt cx="0" cy="0"/>
+        </a:xfrm>
+      </p:grpSpPr>
       <p:sp>
         <p:nvSpPr>
           <p:cNvPr id="2" name="Rectangle 1"/>
@@ -7499,6 +7741,7 @@
           <a:lstStyle/>
           <a:p>
             <a:pPr algn="ctr"/>
+            <a:endParaRPr/>
           </a:p>
         </p:txBody>
       </p:sp>
@@ -7612,6 +7855,7 @@
           <a:lstStyle/>
           <a:p>
             <a:pPr algn="ctr"/>
+            <a:endParaRPr/>
           </a:p>
         </p:txBody>
       </p:sp>
@@ -7690,6 +7934,7 @@
           <a:lstStyle/>
           <a:p>
             <a:pPr algn="ctr"/>
+            <a:endParaRPr/>
           </a:p>
         </p:txBody>
       </p:sp>
@@ -7768,6 +8013,7 @@
           <a:lstStyle/>
           <a:p>
             <a:pPr algn="ctr"/>
+            <a:endParaRPr/>
           </a:p>
         </p:txBody>
       </p:sp>
@@ -7846,6 +8092,7 @@
           <a:lstStyle/>
           <a:p>
             <a:pPr algn="ctr"/>
+            <a:endParaRPr/>
           </a:p>
         </p:txBody>
       </p:sp>
@@ -7924,6 +8171,7 @@
           <a:lstStyle/>
           <a:p>
             <a:pPr algn="ctr"/>
+            <a:endParaRPr/>
           </a:p>
         </p:txBody>
       </p:sp>
@@ -8037,6 +8285,7 @@
           <a:lstStyle/>
           <a:p>
             <a:pPr algn="ctr"/>
+            <a:endParaRPr/>
           </a:p>
         </p:txBody>
       </p:sp>
@@ -8117,6 +8366,7 @@
           <a:lstStyle/>
           <a:p>
             <a:pPr algn="ctr"/>
+            <a:endParaRPr/>
           </a:p>
         </p:txBody>
       </p:sp>

</xml_diff>